<commit_message>
feat(ui): add reload table button fix(database): fix inconsistency in photo file records fix(core): resolve unexpected return during verify photo in managed module refactor(core): restructure GUI and managed module logic perf(core): optimize query execution and loop for better load time feat(core): implement sqltable and tableview reuse chore(assets): add reload icon
</commit_message>
<xml_diff>
--- a/Window Design/Icon Design.pptx
+++ b/Window Design/Icon Design.pptx
@@ -262,7 +262,7 @@
           <a:p>
             <a:fld id="{B8166F3C-C4E3-4D89-8082-A6E2DD4B4902}" type="datetimeFigureOut">
               <a:rPr lang="en-ID" smtClean="0"/>
-              <a:t>15/10/2026</a:t>
+              <a:t>17/10/2026</a:t>
             </a:fld>
             <a:endParaRPr lang="en-ID"/>
           </a:p>
@@ -462,7 +462,7 @@
           <a:p>
             <a:fld id="{B8166F3C-C4E3-4D89-8082-A6E2DD4B4902}" type="datetimeFigureOut">
               <a:rPr lang="en-ID" smtClean="0"/>
-              <a:t>15/10/2026</a:t>
+              <a:t>17/10/2026</a:t>
             </a:fld>
             <a:endParaRPr lang="en-ID"/>
           </a:p>
@@ -672,7 +672,7 @@
           <a:p>
             <a:fld id="{B8166F3C-C4E3-4D89-8082-A6E2DD4B4902}" type="datetimeFigureOut">
               <a:rPr lang="en-ID" smtClean="0"/>
-              <a:t>15/10/2026</a:t>
+              <a:t>17/10/2026</a:t>
             </a:fld>
             <a:endParaRPr lang="en-ID"/>
           </a:p>
@@ -872,7 +872,7 @@
           <a:p>
             <a:fld id="{B8166F3C-C4E3-4D89-8082-A6E2DD4B4902}" type="datetimeFigureOut">
               <a:rPr lang="en-ID" smtClean="0"/>
-              <a:t>15/10/2026</a:t>
+              <a:t>17/10/2026</a:t>
             </a:fld>
             <a:endParaRPr lang="en-ID"/>
           </a:p>
@@ -1148,7 +1148,7 @@
           <a:p>
             <a:fld id="{B8166F3C-C4E3-4D89-8082-A6E2DD4B4902}" type="datetimeFigureOut">
               <a:rPr lang="en-ID" smtClean="0"/>
-              <a:t>15/10/2026</a:t>
+              <a:t>17/10/2026</a:t>
             </a:fld>
             <a:endParaRPr lang="en-ID"/>
           </a:p>
@@ -1416,7 +1416,7 @@
           <a:p>
             <a:fld id="{B8166F3C-C4E3-4D89-8082-A6E2DD4B4902}" type="datetimeFigureOut">
               <a:rPr lang="en-ID" smtClean="0"/>
-              <a:t>15/10/2026</a:t>
+              <a:t>17/10/2026</a:t>
             </a:fld>
             <a:endParaRPr lang="en-ID"/>
           </a:p>
@@ -1831,7 +1831,7 @@
           <a:p>
             <a:fld id="{B8166F3C-C4E3-4D89-8082-A6E2DD4B4902}" type="datetimeFigureOut">
               <a:rPr lang="en-ID" smtClean="0"/>
-              <a:t>15/10/2026</a:t>
+              <a:t>17/10/2026</a:t>
             </a:fld>
             <a:endParaRPr lang="en-ID"/>
           </a:p>
@@ -1973,7 +1973,7 @@
           <a:p>
             <a:fld id="{B8166F3C-C4E3-4D89-8082-A6E2DD4B4902}" type="datetimeFigureOut">
               <a:rPr lang="en-ID" smtClean="0"/>
-              <a:t>15/10/2026</a:t>
+              <a:t>17/10/2026</a:t>
             </a:fld>
             <a:endParaRPr lang="en-ID"/>
           </a:p>
@@ -2086,7 +2086,7 @@
           <a:p>
             <a:fld id="{B8166F3C-C4E3-4D89-8082-A6E2DD4B4902}" type="datetimeFigureOut">
               <a:rPr lang="en-ID" smtClean="0"/>
-              <a:t>15/10/2026</a:t>
+              <a:t>17/10/2026</a:t>
             </a:fld>
             <a:endParaRPr lang="en-ID"/>
           </a:p>
@@ -2399,7 +2399,7 @@
           <a:p>
             <a:fld id="{B8166F3C-C4E3-4D89-8082-A6E2DD4B4902}" type="datetimeFigureOut">
               <a:rPr lang="en-ID" smtClean="0"/>
-              <a:t>15/10/2026</a:t>
+              <a:t>17/10/2026</a:t>
             </a:fld>
             <a:endParaRPr lang="en-ID"/>
           </a:p>
@@ -2688,7 +2688,7 @@
           <a:p>
             <a:fld id="{B8166F3C-C4E3-4D89-8082-A6E2DD4B4902}" type="datetimeFigureOut">
               <a:rPr lang="en-ID" smtClean="0"/>
-              <a:t>15/10/2026</a:t>
+              <a:t>17/10/2026</a:t>
             </a:fld>
             <a:endParaRPr lang="en-ID"/>
           </a:p>
@@ -2931,7 +2931,7 @@
           <a:p>
             <a:fld id="{B8166F3C-C4E3-4D89-8082-A6E2DD4B4902}" type="datetimeFigureOut">
               <a:rPr lang="en-ID" smtClean="0"/>
-              <a:t>15/10/2026</a:t>
+              <a:t>17/10/2026</a:t>
             </a:fld>
             <a:endParaRPr lang="en-ID"/>
           </a:p>
@@ -7603,6 +7603,440 @@
           </a:p>
         </p:txBody>
       </p:sp>
+      <p:sp>
+        <p:nvSpPr>
+          <p:cNvPr id="5" name="Grafik 2">
+            <a:extLst>
+              <a:ext uri="{FF2B5EF4-FFF2-40B4-BE49-F238E27FC236}">
+                <a16:creationId xmlns:a16="http://schemas.microsoft.com/office/drawing/2014/main" id="{840ABB24-24FB-9587-3908-245D52EDC8CD}"/>
+              </a:ext>
+            </a:extLst>
+          </p:cNvPr>
+          <p:cNvSpPr/>
+          <p:nvPr/>
+        </p:nvSpPr>
+        <p:spPr>
+          <a:xfrm>
+            <a:off x="4229268" y="3787798"/>
+            <a:ext cx="1413480" cy="1211573"/>
+          </a:xfrm>
+          <a:custGeom>
+            <a:avLst/>
+            <a:gdLst>
+              <a:gd name="csX0" fmla="*/ 0 w 1413480"/>
+              <a:gd name="csY0" fmla="*/ 605080 h 1211573"/>
+              <a:gd name="csX1" fmla="*/ 48067 w 1413480"/>
+              <a:gd name="csY1" fmla="*/ 370399 h 1211573"/>
+              <a:gd name="csX2" fmla="*/ 176717 w 1413480"/>
+              <a:gd name="csY2" fmla="*/ 176717 h 1211573"/>
+              <a:gd name="csX3" fmla="*/ 370399 w 1413480"/>
+              <a:gd name="csY3" fmla="*/ 48067 h 1211573"/>
+              <a:gd name="csX4" fmla="*/ 606494 w 1413480"/>
+              <a:gd name="csY4" fmla="*/ 0 h 1211573"/>
+              <a:gd name="csX5" fmla="*/ 841174 w 1413480"/>
+              <a:gd name="csY5" fmla="*/ 48067 h 1211573"/>
+              <a:gd name="csX6" fmla="*/ 1034856 w 1413480"/>
+              <a:gd name="csY6" fmla="*/ 176717 h 1211573"/>
+              <a:gd name="csX7" fmla="*/ 1163506 w 1413480"/>
+              <a:gd name="csY7" fmla="*/ 370399 h 1211573"/>
+              <a:gd name="csX8" fmla="*/ 1211574 w 1413480"/>
+              <a:gd name="csY8" fmla="*/ 605080 h 1211573"/>
+              <a:gd name="csX9" fmla="*/ 1313363 w 1413480"/>
+              <a:gd name="csY9" fmla="*/ 605080 h 1211573"/>
+              <a:gd name="csX10" fmla="*/ 1369912 w 1413480"/>
+              <a:gd name="csY10" fmla="*/ 623459 h 1211573"/>
+              <a:gd name="csX11" fmla="*/ 1405256 w 1413480"/>
+              <a:gd name="csY11" fmla="*/ 668698 h 1211573"/>
+              <a:gd name="csX12" fmla="*/ 1412324 w 1413480"/>
+              <a:gd name="csY12" fmla="*/ 725248 h 1211573"/>
+              <a:gd name="csX13" fmla="*/ 1384050 w 1413480"/>
+              <a:gd name="csY13" fmla="*/ 777556 h 1211573"/>
+              <a:gd name="csX14" fmla="*/ 1181885 w 1413480"/>
+              <a:gd name="csY14" fmla="*/ 979720 h 1211573"/>
+              <a:gd name="csX15" fmla="*/ 1111198 w 1413480"/>
+              <a:gd name="csY15" fmla="*/ 1009409 h 1211573"/>
+              <a:gd name="csX16" fmla="*/ 1039097 w 1413480"/>
+              <a:gd name="csY16" fmla="*/ 979720 h 1211573"/>
+              <a:gd name="csX17" fmla="*/ 836933 w 1413480"/>
+              <a:gd name="csY17" fmla="*/ 777556 h 1211573"/>
+              <a:gd name="csX18" fmla="*/ 810072 w 1413480"/>
+              <a:gd name="csY18" fmla="*/ 725248 h 1211573"/>
+              <a:gd name="csX19" fmla="*/ 815727 w 1413480"/>
+              <a:gd name="csY19" fmla="*/ 668698 h 1211573"/>
+              <a:gd name="csX20" fmla="*/ 851070 w 1413480"/>
+              <a:gd name="csY20" fmla="*/ 623459 h 1211573"/>
+              <a:gd name="csX21" fmla="*/ 909034 w 1413480"/>
+              <a:gd name="csY21" fmla="*/ 605080 h 1211573"/>
+              <a:gd name="csX22" fmla="*/ 1009409 w 1413480"/>
+              <a:gd name="csY22" fmla="*/ 605080 h 1211573"/>
+              <a:gd name="csX23" fmla="*/ 955687 w 1413480"/>
+              <a:gd name="csY23" fmla="*/ 402915 h 1211573"/>
+              <a:gd name="csX24" fmla="*/ 808658 w 1413480"/>
+              <a:gd name="csY24" fmla="*/ 255887 h 1211573"/>
+              <a:gd name="csX25" fmla="*/ 606494 w 1413480"/>
+              <a:gd name="csY25" fmla="*/ 202165 h 1211573"/>
+              <a:gd name="csX26" fmla="*/ 402915 w 1413480"/>
+              <a:gd name="csY26" fmla="*/ 255887 h 1211573"/>
+              <a:gd name="csX27" fmla="*/ 255887 w 1413480"/>
+              <a:gd name="csY27" fmla="*/ 402915 h 1211573"/>
+              <a:gd name="csX28" fmla="*/ 202165 w 1413480"/>
+              <a:gd name="csY28" fmla="*/ 605080 h 1211573"/>
+              <a:gd name="csX29" fmla="*/ 255887 w 1413480"/>
+              <a:gd name="csY29" fmla="*/ 808658 h 1211573"/>
+              <a:gd name="csX30" fmla="*/ 402915 w 1413480"/>
+              <a:gd name="csY30" fmla="*/ 955687 h 1211573"/>
+              <a:gd name="csX31" fmla="*/ 606494 w 1413480"/>
+              <a:gd name="csY31" fmla="*/ 1009409 h 1211573"/>
+              <a:gd name="csX32" fmla="*/ 754936 w 1413480"/>
+              <a:gd name="csY32" fmla="*/ 981134 h 1211573"/>
+              <a:gd name="csX33" fmla="*/ 906206 w 1413480"/>
+              <a:gd name="csY33" fmla="*/ 1130990 h 1211573"/>
+              <a:gd name="csX34" fmla="*/ 606494 w 1413480"/>
+              <a:gd name="csY34" fmla="*/ 1211574 h 1211573"/>
+              <a:gd name="csX35" fmla="*/ 370399 w 1413480"/>
+              <a:gd name="csY35" fmla="*/ 1163506 h 1211573"/>
+              <a:gd name="csX36" fmla="*/ 176717 w 1413480"/>
+              <a:gd name="csY36" fmla="*/ 1034856 h 1211573"/>
+              <a:gd name="csX37" fmla="*/ 48067 w 1413480"/>
+              <a:gd name="csY37" fmla="*/ 841174 h 1211573"/>
+              <a:gd name="csX38" fmla="*/ 0 w 1413480"/>
+              <a:gd name="csY38" fmla="*/ 605080 h 1211573"/>
+            </a:gdLst>
+            <a:ahLst/>
+            <a:cxnLst>
+              <a:cxn ang="0">
+                <a:pos x="csX0" y="csY0"/>
+              </a:cxn>
+              <a:cxn ang="0">
+                <a:pos x="csX1" y="csY1"/>
+              </a:cxn>
+              <a:cxn ang="0">
+                <a:pos x="csX2" y="csY2"/>
+              </a:cxn>
+              <a:cxn ang="0">
+                <a:pos x="csX3" y="csY3"/>
+              </a:cxn>
+              <a:cxn ang="0">
+                <a:pos x="csX4" y="csY4"/>
+              </a:cxn>
+              <a:cxn ang="0">
+                <a:pos x="csX5" y="csY5"/>
+              </a:cxn>
+              <a:cxn ang="0">
+                <a:pos x="csX6" y="csY6"/>
+              </a:cxn>
+              <a:cxn ang="0">
+                <a:pos x="csX7" y="csY7"/>
+              </a:cxn>
+              <a:cxn ang="0">
+                <a:pos x="csX8" y="csY8"/>
+              </a:cxn>
+              <a:cxn ang="0">
+                <a:pos x="csX9" y="csY9"/>
+              </a:cxn>
+              <a:cxn ang="0">
+                <a:pos x="csX10" y="csY10"/>
+              </a:cxn>
+              <a:cxn ang="0">
+                <a:pos x="csX11" y="csY11"/>
+              </a:cxn>
+              <a:cxn ang="0">
+                <a:pos x="csX12" y="csY12"/>
+              </a:cxn>
+              <a:cxn ang="0">
+                <a:pos x="csX13" y="csY13"/>
+              </a:cxn>
+              <a:cxn ang="0">
+                <a:pos x="csX14" y="csY14"/>
+              </a:cxn>
+              <a:cxn ang="0">
+                <a:pos x="csX15" y="csY15"/>
+              </a:cxn>
+              <a:cxn ang="0">
+                <a:pos x="csX16" y="csY16"/>
+              </a:cxn>
+              <a:cxn ang="0">
+                <a:pos x="csX17" y="csY17"/>
+              </a:cxn>
+              <a:cxn ang="0">
+                <a:pos x="csX18" y="csY18"/>
+              </a:cxn>
+              <a:cxn ang="0">
+                <a:pos x="csX19" y="csY19"/>
+              </a:cxn>
+              <a:cxn ang="0">
+                <a:pos x="csX20" y="csY20"/>
+              </a:cxn>
+              <a:cxn ang="0">
+                <a:pos x="csX21" y="csY21"/>
+              </a:cxn>
+              <a:cxn ang="0">
+                <a:pos x="csX22" y="csY22"/>
+              </a:cxn>
+              <a:cxn ang="0">
+                <a:pos x="csX23" y="csY23"/>
+              </a:cxn>
+              <a:cxn ang="0">
+                <a:pos x="csX24" y="csY24"/>
+              </a:cxn>
+              <a:cxn ang="0">
+                <a:pos x="csX25" y="csY25"/>
+              </a:cxn>
+              <a:cxn ang="0">
+                <a:pos x="csX26" y="csY26"/>
+              </a:cxn>
+              <a:cxn ang="0">
+                <a:pos x="csX27" y="csY27"/>
+              </a:cxn>
+              <a:cxn ang="0">
+                <a:pos x="csX28" y="csY28"/>
+              </a:cxn>
+              <a:cxn ang="0">
+                <a:pos x="csX29" y="csY29"/>
+              </a:cxn>
+              <a:cxn ang="0">
+                <a:pos x="csX30" y="csY30"/>
+              </a:cxn>
+              <a:cxn ang="0">
+                <a:pos x="csX31" y="csY31"/>
+              </a:cxn>
+              <a:cxn ang="0">
+                <a:pos x="csX32" y="csY32"/>
+              </a:cxn>
+              <a:cxn ang="0">
+                <a:pos x="csX33" y="csY33"/>
+              </a:cxn>
+              <a:cxn ang="0">
+                <a:pos x="csX34" y="csY34"/>
+              </a:cxn>
+              <a:cxn ang="0">
+                <a:pos x="csX35" y="csY35"/>
+              </a:cxn>
+              <a:cxn ang="0">
+                <a:pos x="csX36" y="csY36"/>
+              </a:cxn>
+              <a:cxn ang="0">
+                <a:pos x="csX37" y="csY37"/>
+              </a:cxn>
+              <a:cxn ang="0">
+                <a:pos x="csX38" y="csY38"/>
+              </a:cxn>
+            </a:cxnLst>
+            <a:rect l="l" t="t" r="r" b="b"/>
+            <a:pathLst>
+              <a:path w="1413480" h="1211573">
+                <a:moveTo>
+                  <a:pt x="0" y="605080"/>
+                </a:moveTo>
+                <a:cubicBezTo>
+                  <a:pt x="0" y="523083"/>
+                  <a:pt x="16022" y="444856"/>
+                  <a:pt x="48067" y="370399"/>
+                </a:cubicBezTo>
+                <a:cubicBezTo>
+                  <a:pt x="80112" y="295942"/>
+                  <a:pt x="122995" y="231382"/>
+                  <a:pt x="176717" y="176717"/>
+                </a:cubicBezTo>
+                <a:cubicBezTo>
+                  <a:pt x="230439" y="122053"/>
+                  <a:pt x="295000" y="79169"/>
+                  <a:pt x="370399" y="48067"/>
+                </a:cubicBezTo>
+                <a:cubicBezTo>
+                  <a:pt x="445799" y="16965"/>
+                  <a:pt x="524497" y="942"/>
+                  <a:pt x="606494" y="0"/>
+                </a:cubicBezTo>
+                <a:cubicBezTo>
+                  <a:pt x="688490" y="0"/>
+                  <a:pt x="766717" y="16022"/>
+                  <a:pt x="841174" y="48067"/>
+                </a:cubicBezTo>
+                <a:cubicBezTo>
+                  <a:pt x="915631" y="80112"/>
+                  <a:pt x="980192" y="122995"/>
+                  <a:pt x="1034856" y="176717"/>
+                </a:cubicBezTo>
+                <a:cubicBezTo>
+                  <a:pt x="1089521" y="230439"/>
+                  <a:pt x="1132404" y="295000"/>
+                  <a:pt x="1163506" y="370399"/>
+                </a:cubicBezTo>
+                <a:cubicBezTo>
+                  <a:pt x="1194609" y="445799"/>
+                  <a:pt x="1210631" y="524026"/>
+                  <a:pt x="1211574" y="605080"/>
+                </a:cubicBezTo>
+                <a:lnTo>
+                  <a:pt x="1313363" y="605080"/>
+                </a:lnTo>
+                <a:cubicBezTo>
+                  <a:pt x="1335040" y="605080"/>
+                  <a:pt x="1353890" y="611206"/>
+                  <a:pt x="1369912" y="623459"/>
+                </a:cubicBezTo>
+                <a:cubicBezTo>
+                  <a:pt x="1385935" y="635711"/>
+                  <a:pt x="1397716" y="650791"/>
+                  <a:pt x="1405256" y="668698"/>
+                </a:cubicBezTo>
+                <a:cubicBezTo>
+                  <a:pt x="1412796" y="686605"/>
+                  <a:pt x="1415152" y="705455"/>
+                  <a:pt x="1412324" y="725248"/>
+                </a:cubicBezTo>
+                <a:cubicBezTo>
+                  <a:pt x="1409497" y="745040"/>
+                  <a:pt x="1400072" y="762476"/>
+                  <a:pt x="1384050" y="777556"/>
+                </a:cubicBezTo>
+                <a:lnTo>
+                  <a:pt x="1181885" y="979720"/>
+                </a:lnTo>
+                <a:cubicBezTo>
+                  <a:pt x="1162093" y="999513"/>
+                  <a:pt x="1138530" y="1009409"/>
+                  <a:pt x="1111198" y="1009409"/>
+                </a:cubicBezTo>
+                <a:cubicBezTo>
+                  <a:pt x="1083866" y="1009409"/>
+                  <a:pt x="1059832" y="999513"/>
+                  <a:pt x="1039097" y="979720"/>
+                </a:cubicBezTo>
+                <a:lnTo>
+                  <a:pt x="836933" y="777556"/>
+                </a:lnTo>
+                <a:cubicBezTo>
+                  <a:pt x="821853" y="762476"/>
+                  <a:pt x="812899" y="745040"/>
+                  <a:pt x="810072" y="725248"/>
+                </a:cubicBezTo>
+                <a:cubicBezTo>
+                  <a:pt x="807244" y="705455"/>
+                  <a:pt x="809129" y="686605"/>
+                  <a:pt x="815727" y="668698"/>
+                </a:cubicBezTo>
+                <a:cubicBezTo>
+                  <a:pt x="822324" y="650791"/>
+                  <a:pt x="834105" y="635711"/>
+                  <a:pt x="851070" y="623459"/>
+                </a:cubicBezTo>
+                <a:cubicBezTo>
+                  <a:pt x="868035" y="611206"/>
+                  <a:pt x="887356" y="605080"/>
+                  <a:pt x="909034" y="605080"/>
+                </a:cubicBezTo>
+                <a:lnTo>
+                  <a:pt x="1009409" y="605080"/>
+                </a:lnTo>
+                <a:cubicBezTo>
+                  <a:pt x="1009409" y="532508"/>
+                  <a:pt x="991502" y="465120"/>
+                  <a:pt x="955687" y="402915"/>
+                </a:cubicBezTo>
+                <a:cubicBezTo>
+                  <a:pt x="919872" y="340711"/>
+                  <a:pt x="870863" y="291701"/>
+                  <a:pt x="808658" y="255887"/>
+                </a:cubicBezTo>
+                <a:cubicBezTo>
+                  <a:pt x="746454" y="220072"/>
+                  <a:pt x="679066" y="202165"/>
+                  <a:pt x="606494" y="202165"/>
+                </a:cubicBezTo>
+                <a:cubicBezTo>
+                  <a:pt x="533922" y="202165"/>
+                  <a:pt x="466062" y="220072"/>
+                  <a:pt x="402915" y="255887"/>
+                </a:cubicBezTo>
+                <a:cubicBezTo>
+                  <a:pt x="339768" y="291701"/>
+                  <a:pt x="290759" y="340711"/>
+                  <a:pt x="255887" y="402915"/>
+                </a:cubicBezTo>
+                <a:cubicBezTo>
+                  <a:pt x="221014" y="465120"/>
+                  <a:pt x="203107" y="532508"/>
+                  <a:pt x="202165" y="605080"/>
+                </a:cubicBezTo>
+                <a:cubicBezTo>
+                  <a:pt x="201222" y="677652"/>
+                  <a:pt x="219129" y="745511"/>
+                  <a:pt x="255887" y="808658"/>
+                </a:cubicBezTo>
+                <a:cubicBezTo>
+                  <a:pt x="292644" y="871805"/>
+                  <a:pt x="341653" y="920815"/>
+                  <a:pt x="402915" y="955687"/>
+                </a:cubicBezTo>
+                <a:cubicBezTo>
+                  <a:pt x="464177" y="990559"/>
+                  <a:pt x="532037" y="1008466"/>
+                  <a:pt x="606494" y="1009409"/>
+                </a:cubicBezTo>
+                <a:cubicBezTo>
+                  <a:pt x="657388" y="1009409"/>
+                  <a:pt x="706869" y="999984"/>
+                  <a:pt x="754936" y="981134"/>
+                </a:cubicBezTo>
+                <a:lnTo>
+                  <a:pt x="906206" y="1130990"/>
+                </a:lnTo>
+                <a:cubicBezTo>
+                  <a:pt x="813842" y="1184712"/>
+                  <a:pt x="713938" y="1211574"/>
+                  <a:pt x="606494" y="1211574"/>
+                </a:cubicBezTo>
+                <a:cubicBezTo>
+                  <a:pt x="523554" y="1211574"/>
+                  <a:pt x="444856" y="1195551"/>
+                  <a:pt x="370399" y="1163506"/>
+                </a:cubicBezTo>
+                <a:cubicBezTo>
+                  <a:pt x="295942" y="1131462"/>
+                  <a:pt x="231382" y="1088578"/>
+                  <a:pt x="176717" y="1034856"/>
+                </a:cubicBezTo>
+                <a:cubicBezTo>
+                  <a:pt x="122053" y="981134"/>
+                  <a:pt x="79169" y="916574"/>
+                  <a:pt x="48067" y="841174"/>
+                </a:cubicBezTo>
+                <a:cubicBezTo>
+                  <a:pt x="16965" y="765775"/>
+                  <a:pt x="942" y="687077"/>
+                  <a:pt x="0" y="605080"/>
+                </a:cubicBezTo>
+                <a:close/>
+              </a:path>
+            </a:pathLst>
+          </a:custGeom>
+          <a:noFill/>
+          <a:ln w="44053" cap="flat">
+            <a:gradFill>
+              <a:gsLst>
+                <a:gs pos="0">
+                  <a:srgbClr val="346A4F"/>
+                </a:gs>
+                <a:gs pos="100000">
+                  <a:srgbClr val="F3BB1D"/>
+                </a:gs>
+              </a:gsLst>
+              <a:lin ang="7200000" scaled="0"/>
+            </a:gradFill>
+            <a:prstDash val="solid"/>
+            <a:miter/>
+          </a:ln>
+        </p:spPr>
+        <p:txBody>
+          <a:bodyPr/>
+          <a:lstStyle/>
+          <a:p>
+            <a:endParaRPr lang="en-ID"/>
+          </a:p>
+        </p:txBody>
+      </p:sp>
     </p:spTree>
     <p:extLst>
       <p:ext uri="{BB962C8B-B14F-4D97-AF65-F5344CB8AC3E}">

</xml_diff>